<commit_message>
docs: show counts and intervals behind the non-monotonic hit rate
Hit rates of 93.9 / 97.0 / 90.9 % at 1/2/3-day leads are 31, 32 and 30 of
only 33 dangerous mornings; Wilson 95% intervals overlap almost entirely.
The 2-day "rise" is one morning, bought with 6 extra false alarms. CSI
falls monotonically (91.2 -> 80.0 -> 65.2 %).

Numbers unchanged. Synopsis section 5 and slide 9 now show warned-of-33,
false-alarm counts and intervals beside the percentages, with a short
explanation; the script adds a slide 9 line and a prepared Q&A answer.

Co-Authored-By: Claude Opus 5.5 <noreply@anthropic.com>
</commit_message>
<xml_diff>
--- a/docs/Sagar_Setu_MidTerm.pptx
+++ b/docs/Sagar_Setu_MidTerm.pptx
@@ -116,40 +116,40 @@
   <p:extLst>
     <p:ext uri="{521415D9-36F7-43E2-AB2F-B90AF26B5E84}">
       <p14:sectionLst xmlns:p14="http://schemas.microsoft.com/office/powerpoint/2010/main">
-        <p14:section name="Opening" id="{c1380498-7771-0178-c758-c20582852c14}">
+        <p14:section name="Opening" id="{15444fd0-9ef8-3415-cce9-7dfd8309eb5f}">
           <p14:sldIdLst>
             <p14:sldId id="256"/>
           </p14:sldIdLst>
         </p14:section>
-        <p14:section name="Problem definition" id="{2a864566-00e2-8b88-0fc5-a897eeb6e029}">
+        <p14:section name="Problem definition" id="{cf0a2f7c-da17-b96d-482c-99f3c18bdd3b}">
           <p14:sldIdLst>
             <p14:sldId id="257"/>
           </p14:sldIdLst>
         </p14:section>
-        <p14:section name="Literature survey" id="{056b894f-04a4-1446-90c1-ed20565b7986}">
+        <p14:section name="Literature survey" id="{6514fcd3-e2b9-4006-5f86-541cf8a0e741}">
           <p14:sldIdLst>
             <p14:sldId id="258"/>
             <p14:sldId id="259"/>
           </p14:sldIdLst>
         </p14:section>
-        <p14:section name="Research gap" id="{5817fbd3-5045-674c-b916-1d7b8f034e28}">
+        <p14:section name="Research gap" id="{56246817-a57f-5aad-3ce4-64f091d0f13d}">
           <p14:sldIdLst>
             <p14:sldId id="260"/>
             <p14:sldId id="261"/>
           </p14:sldIdLst>
         </p14:section>
-        <p14:section name="Methodology" id="{90f714b2-363d-0b87-680b-e6116b2ed3db}">
+        <p14:section name="Methodology" id="{b70e8d40-b170-cca9-0821-adddb4227347}">
           <p14:sldIdLst>
             <p14:sldId id="262"/>
             <p14:sldId id="263"/>
           </p14:sldIdLst>
         </p14:section>
-        <p14:section name="Evaluation" id="{02843651-024f-6fba-43b0-89b11523736b}">
+        <p14:section name="Evaluation" id="{9229faaf-0ed3-5b44-6012-7110fe2bde01}">
           <p14:sldIdLst>
             <p14:sldId id="264"/>
           </p14:sldIdLst>
         </p14:section>
-        <p14:section name="References" id="{cc3c6e13-f920-0c11-0afe-f78e3dc74864}">
+        <p14:section name="References" id="{77cb32ec-9492-72bd-b316-d60b50e7bcd4}">
           <p14:sldIdLst>
             <p14:sldId id="265"/>
           </p14:sldIdLst>
@@ -19536,11 +19536,11 @@
         <p:spPr>
           <a:xfrm>
             <a:off x="502920" y="1188720"/>
-            <a:ext cx="4526280" cy="2514600"/>
+            <a:ext cx="4526280" cy="2286000"/>
           </a:xfrm>
           <a:prstGeom prst="roundRect">
             <a:avLst>
-              <a:gd name="adj" fmla="val 2909"/>
+              <a:gd name="adj" fmla="val 3200"/>
             </a:avLst>
           </a:prstGeom>
           <a:solidFill>
@@ -19599,7 +19599,7 @@
         <p:spPr>
           <a:xfrm>
             <a:off x="740664" y="1719072"/>
-            <a:ext cx="4069080" cy="1874520"/>
+            <a:ext cx="4069080" cy="1645920"/>
           </a:xfrm>
           <a:prstGeom prst="rect">
             <a:avLst/>
@@ -19769,7 +19769,7 @@
         <p:spPr>
           <a:xfrm>
             <a:off x="5257800" y="1188720"/>
-            <a:ext cx="2021738" cy="2514600"/>
+            <a:ext cx="2021738" cy="2286000"/>
           </a:xfrm>
           <a:prstGeom prst="roundRect">
             <a:avLst>
@@ -19907,7 +19907,7 @@
         <p:spPr>
           <a:xfrm>
             <a:off x="7462418" y="1188720"/>
-            <a:ext cx="2021738" cy="2514600"/>
+            <a:ext cx="2021738" cy="2286000"/>
           </a:xfrm>
           <a:prstGeom prst="roundRect">
             <a:avLst>
@@ -20045,7 +20045,7 @@
         <p:spPr>
           <a:xfrm>
             <a:off x="9667037" y="1188720"/>
-            <a:ext cx="2021738" cy="2514600"/>
+            <a:ext cx="2021738" cy="2286000"/>
           </a:xfrm>
           <a:prstGeom prst="roundRect">
             <a:avLst>
@@ -20189,7 +20189,7 @@
           </p:nvPr>
         </p:nvGraphicFramePr>
         <p:xfrm>
-          <a:off x="502920" y="3886200"/>
+          <a:off x="502920" y="3639312"/>
           <a:ext cx="11185855" cy="914400"/>
         </p:xfrm>
         <a:graphic>
@@ -20197,12 +20197,12 @@
             <a:tbl>
               <a:tblPr/>
               <a:tblGrid>
-                <a:gridCol w="2377440"/>
-                <a:gridCol w="1097280"/>
-                <a:gridCol w="2011680"/>
-                <a:gridCol w="2194560"/>
+                <a:gridCol w="1965960"/>
+                <a:gridCol w="2240280"/>
+                <a:gridCol w="1691640"/>
                 <a:gridCol w="1463040"/>
-                <a:gridCol w="2041855"/>
+                <a:gridCol w="1828800"/>
+                <a:gridCol w="1996135"/>
               </a:tblGrid>
               <a:tr h="310896">
                 <a:tc>
@@ -20290,7 +20290,7 @@
                           <a:ea typeface="Calibri" pitchFamily="34" charset="-122"/>
                           <a:cs typeface="Calibri" pitchFamily="34" charset="-120"/>
                         </a:rPr>
-                        <a:t>n</a:t>
+                        <a:t>Warned (of 33)</a:t>
                       </a:r>
                       <a:endParaRPr lang="en-US" sz="1200" dirty="0">
                         <a:latin typeface="Calibri" charset="0"/>
@@ -20426,7 +20426,7 @@
                           <a:ea typeface="Calibri" pitchFamily="34" charset="-122"/>
                           <a:cs typeface="Calibri" pitchFamily="34" charset="-120"/>
                         </a:rPr>
-                        <a:t>False-alarm ratio</a:t>
+                        <a:t>False alarms</a:t>
                       </a:r>
                       <a:endParaRPr lang="en-US" sz="1200" dirty="0">
                         <a:latin typeface="Calibri" charset="0"/>
@@ -20494,7 +20494,7 @@
                           <a:ea typeface="Calibri" pitchFamily="34" charset="-122"/>
                           <a:cs typeface="Calibri" pitchFamily="34" charset="-120"/>
                         </a:rPr>
-                        <a:t>CSI</a:t>
+                        <a:t>False-alarm ratio</a:t>
                       </a:r>
                       <a:endParaRPr lang="en-US" sz="1200" dirty="0">
                         <a:latin typeface="Calibri" charset="0"/>
@@ -20562,7 +20562,7 @@
                           <a:ea typeface="Calibri" pitchFamily="34" charset="-122"/>
                           <a:cs typeface="Calibri" pitchFamily="34" charset="-120"/>
                         </a:rPr>
-                        <a:t>3-way agreement</a:t>
+                        <a:t>CSI (overall skill)</a:t>
                       </a:r>
                       <a:endParaRPr lang="en-US" sz="1200" dirty="0">
                         <a:latin typeface="Calibri" charset="0"/>
@@ -20700,7 +20700,7 @@
                           <a:ea typeface="Calibri" pitchFamily="34" charset="-122"/>
                           <a:cs typeface="Calibri" pitchFamily="34" charset="-120"/>
                         </a:rPr>
-                        <a:t>460</a:t>
+                        <a:t>31 of 33</a:t>
                       </a:r>
                       <a:endParaRPr lang="en-US" sz="1250" dirty="0">
                         <a:latin typeface="Calibri" charset="0"/>
@@ -20836,7 +20836,7 @@
                           <a:ea typeface="Calibri" pitchFamily="34" charset="-122"/>
                           <a:cs typeface="Calibri" pitchFamily="34" charset="-120"/>
                         </a:rPr>
-                        <a:t>3.1 %</a:t>
+                        <a:t>1</a:t>
                       </a:r>
                       <a:endParaRPr lang="en-US" sz="1250" dirty="0">
                         <a:latin typeface="Calibri" charset="0"/>
@@ -20904,7 +20904,7 @@
                           <a:ea typeface="Calibri" pitchFamily="34" charset="-122"/>
                           <a:cs typeface="Calibri" pitchFamily="34" charset="-120"/>
                         </a:rPr>
-                        <a:t>91.2 %</a:t>
+                        <a:t>3.1 %</a:t>
                       </a:r>
                       <a:endParaRPr lang="en-US" sz="1250" dirty="0">
                         <a:latin typeface="Calibri" charset="0"/>
@@ -20972,7 +20972,7 @@
                           <a:ea typeface="Calibri" pitchFamily="34" charset="-122"/>
                           <a:cs typeface="Calibri" pitchFamily="34" charset="-120"/>
                         </a:rPr>
-                        <a:t>93.5 %</a:t>
+                        <a:t>91.2 %</a:t>
                       </a:r>
                       <a:endParaRPr lang="en-US" sz="1250" dirty="0">
                         <a:latin typeface="Calibri" charset="0"/>
@@ -21110,7 +21110,7 @@
                           <a:ea typeface="Calibri" pitchFamily="34" charset="-122"/>
                           <a:cs typeface="Calibri" pitchFamily="34" charset="-120"/>
                         </a:rPr>
-                        <a:t>460</a:t>
+                        <a:t>32 of 33</a:t>
                       </a:r>
                       <a:endParaRPr lang="en-US" sz="1250" dirty="0">
                         <a:latin typeface="Calibri" charset="0"/>
@@ -21246,7 +21246,7 @@
                           <a:ea typeface="Calibri" pitchFamily="34" charset="-122"/>
                           <a:cs typeface="Calibri" pitchFamily="34" charset="-120"/>
                         </a:rPr>
-                        <a:t>17.9 %</a:t>
+                        <a:t>7</a:t>
                       </a:r>
                       <a:endParaRPr lang="en-US" sz="1250" dirty="0">
                         <a:latin typeface="Calibri" charset="0"/>
@@ -21314,7 +21314,7 @@
                           <a:ea typeface="Calibri" pitchFamily="34" charset="-122"/>
                           <a:cs typeface="Calibri" pitchFamily="34" charset="-120"/>
                         </a:rPr>
-                        <a:t>80.0 %</a:t>
+                        <a:t>17.9 %</a:t>
                       </a:r>
                       <a:endParaRPr lang="en-US" sz="1250" dirty="0">
                         <a:latin typeface="Calibri" charset="0"/>
@@ -21382,7 +21382,7 @@
                           <a:ea typeface="Calibri" pitchFamily="34" charset="-122"/>
                           <a:cs typeface="Calibri" pitchFamily="34" charset="-120"/>
                         </a:rPr>
-                        <a:t>90.2 %</a:t>
+                        <a:t>80.0 %</a:t>
                       </a:r>
                       <a:endParaRPr lang="en-US" sz="1250" dirty="0">
                         <a:latin typeface="Calibri" charset="0"/>
@@ -21520,7 +21520,7 @@
                           <a:ea typeface="Calibri" pitchFamily="34" charset="-122"/>
                           <a:cs typeface="Calibri" pitchFamily="34" charset="-120"/>
                         </a:rPr>
-                        <a:t>460</a:t>
+                        <a:t>30 of 33</a:t>
                       </a:r>
                       <a:endParaRPr lang="en-US" sz="1250" dirty="0">
                         <a:latin typeface="Calibri" charset="0"/>
@@ -21656,7 +21656,7 @@
                           <a:ea typeface="Calibri" pitchFamily="34" charset="-122"/>
                           <a:cs typeface="Calibri" pitchFamily="34" charset="-120"/>
                         </a:rPr>
-                        <a:t>30.2 %</a:t>
+                        <a:t>13</a:t>
                       </a:r>
                       <a:endParaRPr lang="en-US" sz="1250" dirty="0">
                         <a:latin typeface="Calibri" charset="0"/>
@@ -21724,7 +21724,7 @@
                           <a:ea typeface="Calibri" pitchFamily="34" charset="-122"/>
                           <a:cs typeface="Calibri" pitchFamily="34" charset="-120"/>
                         </a:rPr>
-                        <a:t>65.2 %</a:t>
+                        <a:t>30.2 %</a:t>
                       </a:r>
                       <a:endParaRPr lang="en-US" sz="1250" dirty="0">
                         <a:latin typeface="Calibri" charset="0"/>
@@ -21792,7 +21792,7 @@
                           <a:ea typeface="Calibri" pitchFamily="34" charset="-122"/>
                           <a:cs typeface="Calibri" pitchFamily="34" charset="-120"/>
                         </a:rPr>
-                        <a:t>85.0 %</a:t>
+                        <a:t>65.2 %</a:t>
                       </a:r>
                       <a:endParaRPr lang="en-US" sz="1250" dirty="0">
                         <a:latin typeface="Calibri" charset="0"/>
@@ -21850,18 +21850,65 @@
       </p:graphicFrame>
       <p:sp>
         <p:nvSpPr>
-          <p:cNvPr id="21" name="Shape 18"/>
+          <p:cNvPr id="21" name="Text 18"/>
+          <p:cNvSpPr txBox="1"/>
+          <p:nvPr/>
+        </p:nvSpPr>
+        <p:spPr>
+          <a:xfrm>
+            <a:off x="502920" y="4937760"/>
+            <a:ext cx="11185855" cy="292608"/>
+          </a:xfrm>
+          <a:prstGeom prst="rect">
+            <a:avLst/>
+          </a:prstGeom>
+          <a:noFill/>
+          <a:ln/>
+        </p:spPr>
+        <p:txBody>
+          <a:bodyPr wrap="square" lIns="0" tIns="0" rIns="0" bIns="0" rtlCol="0" anchor="ctr"/>
+          <a:lstStyle/>
+          <a:p>
+            <a:pPr indent="0" marL="0">
+              <a:buNone/>
+            </a:pPr>
+            <a:r>
+              <a:rPr lang="en-US" sz="1150" b="1" dirty="0">
+                <a:solidFill>
+                  <a:srgbClr val="0F1E2E"/>
+                </a:solidFill>
+              </a:rPr>
+              <a:t>Only 33 dangerous mornings: one morning ≈ 3 points of hit rate. </a:t>
+            </a:r>
+            <a:pPr indent="0" marL="0">
+              <a:buNone/>
+            </a:pPr>
+            <a:r>
+              <a:rPr lang="en-US" sz="1150" dirty="0">
+                <a:solidFill>
+                  <a:srgbClr val="3A4A58"/>
+                </a:solidFill>
+              </a:rPr>
+              <a:t>The 2-day “rise” is one extra catch, bought with 6 more false alarms.</a:t>
+            </a:r>
+            <a:endParaRPr lang="en-US" sz="1150" dirty="0"/>
+          </a:p>
+        </p:txBody>
+      </p:sp>
+      <p:sp>
+        <p:nvSpPr>
+          <p:cNvPr id="22" name="Shape 19"/>
           <p:cNvSpPr/>
           <p:nvPr/>
         </p:nvSpPr>
         <p:spPr>
           <a:xfrm>
-            <a:off x="502920" y="5285232"/>
-            <a:ext cx="11185855" cy="457200"/>
+            <a:off x="502920" y="5376672"/>
+            <a:ext cx="11185855" cy="420624"/>
           </a:xfrm>
           <a:prstGeom prst="roundRect">
             <a:avLst>
-              <a:gd name="adj" fmla="val 16000"/>
+              <a:gd name="adj" fmla="val 17391"/>
             </a:avLst>
           </a:prstGeom>
           <a:solidFill>
@@ -21877,14 +21924,14 @@
       </p:sp>
       <p:sp>
         <p:nvSpPr>
-          <p:cNvPr id="22" name="Text 19"/>
+          <p:cNvPr id="23" name="Text 20"/>
           <p:cNvSpPr txBox="1"/>
           <p:nvPr/>
         </p:nvSpPr>
         <p:spPr>
           <a:xfrm>
-            <a:off x="758952" y="5285232"/>
-            <a:ext cx="10673791" cy="457200"/>
+            <a:off x="758952" y="5376672"/>
+            <a:ext cx="10673791" cy="420624"/>
           </a:xfrm>
           <a:prstGeom prst="rect">
             <a:avLst/>
@@ -21913,14 +21960,14 @@
       </p:sp>
       <p:sp>
         <p:nvSpPr>
-          <p:cNvPr id="23" name="Text 20"/>
+          <p:cNvPr id="24" name="Text 21"/>
           <p:cNvSpPr txBox="1"/>
           <p:nvPr/>
         </p:nvSpPr>
         <p:spPr>
           <a:xfrm>
-            <a:off x="502920" y="5833872"/>
-            <a:ext cx="11185855" cy="457200"/>
+            <a:off x="502920" y="5870448"/>
+            <a:ext cx="11185855" cy="420624"/>
           </a:xfrm>
           <a:prstGeom prst="rect">
             <a:avLst/>

</xml_diff>